<commit_message>
added poster presentation for conference
</commit_message>
<xml_diff>
--- a/my_articles/3_course/автореферат/Kolbeko_AB.pptx
+++ b/my_articles/3_course/автореферат/Kolbeko_AB.pptx
@@ -220,7 +220,7 @@
           <a:p>
             <a:fld id="{35C49C6E-035B-4F70-8000-D874F4F10440}" type="datetimeFigureOut">
               <a:rPr lang="ru-RU" smtClean="0"/>
-              <a:t>23.12.2025</a:t>
+              <a:t>21.05.2026</a:t>
             </a:fld>
             <a:endParaRPr lang="ru-RU"/>
           </a:p>
@@ -616,7 +616,7 @@
           <a:p>
             <a:fld id="{33A505B3-F41B-427C-80BB-A688A6689C6B}" type="datetime1">
               <a:rPr lang="ru-RU" smtClean="0"/>
-              <a:t>23.12.2025</a:t>
+              <a:t>21.05.2026</a:t>
             </a:fld>
             <a:endParaRPr lang="ru-RU"/>
           </a:p>
@@ -784,7 +784,7 @@
           <a:p>
             <a:fld id="{B276B4B7-56F2-447E-9729-4D33381F345C}" type="datetime1">
               <a:rPr lang="ru-RU" smtClean="0"/>
-              <a:t>23.12.2025</a:t>
+              <a:t>21.05.2026</a:t>
             </a:fld>
             <a:endParaRPr lang="ru-RU"/>
           </a:p>
@@ -962,7 +962,7 @@
           <a:p>
             <a:fld id="{7E4A6E2F-A8A2-4938-9AC0-DAFE7B1245A6}" type="datetime1">
               <a:rPr lang="ru-RU" smtClean="0"/>
-              <a:t>23.12.2025</a:t>
+              <a:t>21.05.2026</a:t>
             </a:fld>
             <a:endParaRPr lang="ru-RU"/>
           </a:p>
@@ -1130,7 +1130,7 @@
           <a:p>
             <a:fld id="{4FE1C2D5-ED12-4B99-A8E1-39CA7FB09485}" type="datetime1">
               <a:rPr lang="ru-RU" smtClean="0"/>
-              <a:t>23.12.2025</a:t>
+              <a:t>21.05.2026</a:t>
             </a:fld>
             <a:endParaRPr lang="ru-RU"/>
           </a:p>
@@ -1375,7 +1375,7 @@
           <a:p>
             <a:fld id="{44373428-08DD-4DB4-806D-52136AFA4210}" type="datetime1">
               <a:rPr lang="ru-RU" smtClean="0"/>
-              <a:t>23.12.2025</a:t>
+              <a:t>21.05.2026</a:t>
             </a:fld>
             <a:endParaRPr lang="ru-RU"/>
           </a:p>
@@ -1604,7 +1604,7 @@
           <a:p>
             <a:fld id="{FBB1317D-EE05-422C-8BD5-2E1731177917}" type="datetime1">
               <a:rPr lang="ru-RU" smtClean="0"/>
-              <a:t>23.12.2025</a:t>
+              <a:t>21.05.2026</a:t>
             </a:fld>
             <a:endParaRPr lang="ru-RU"/>
           </a:p>
@@ -1968,7 +1968,7 @@
           <a:p>
             <a:fld id="{9B1C2390-4B9D-445F-87EF-CDCBAC486F90}" type="datetime1">
               <a:rPr lang="ru-RU" smtClean="0"/>
-              <a:t>23.12.2025</a:t>
+              <a:t>21.05.2026</a:t>
             </a:fld>
             <a:endParaRPr lang="ru-RU"/>
           </a:p>
@@ -2085,7 +2085,7 @@
           <a:p>
             <a:fld id="{B72FE28B-29F8-4405-84BD-18E16F5BB3A1}" type="datetime1">
               <a:rPr lang="ru-RU" smtClean="0"/>
-              <a:t>23.12.2025</a:t>
+              <a:t>21.05.2026</a:t>
             </a:fld>
             <a:endParaRPr lang="ru-RU"/>
           </a:p>
@@ -2180,7 +2180,7 @@
           <a:p>
             <a:fld id="{28523E67-4852-467E-B482-C068760DAEDE}" type="datetime1">
               <a:rPr lang="ru-RU" smtClean="0"/>
-              <a:t>23.12.2025</a:t>
+              <a:t>21.05.2026</a:t>
             </a:fld>
             <a:endParaRPr lang="ru-RU"/>
           </a:p>
@@ -2455,7 +2455,7 @@
           <a:p>
             <a:fld id="{8C771C97-312D-4E09-923E-7FA261204C8D}" type="datetime1">
               <a:rPr lang="ru-RU" smtClean="0"/>
-              <a:t>23.12.2025</a:t>
+              <a:t>21.05.2026</a:t>
             </a:fld>
             <a:endParaRPr lang="ru-RU"/>
           </a:p>
@@ -2707,7 +2707,7 @@
           <a:p>
             <a:fld id="{82205990-6714-4880-ABDC-58C72C70B6FE}" type="datetime1">
               <a:rPr lang="ru-RU" smtClean="0"/>
-              <a:t>23.12.2025</a:t>
+              <a:t>21.05.2026</a:t>
             </a:fld>
             <a:endParaRPr lang="ru-RU"/>
           </a:p>
@@ -2918,7 +2918,7 @@
           <a:p>
             <a:fld id="{192EE296-6673-4508-83F2-1D7CAC52A998}" type="datetime1">
               <a:rPr lang="ru-RU" smtClean="0"/>
-              <a:t>23.12.2025</a:t>
+              <a:t>21.05.2026</a:t>
             </a:fld>
             <a:endParaRPr lang="ru-RU"/>
           </a:p>
@@ -6937,8 +6937,8 @@
           </p:sp>
         </mc:Fallback>
       </mc:AlternateContent>
-      <mc:AlternateContent xmlns:mc="http://schemas.openxmlformats.org/markup-compatibility/2006" xmlns:a14="http://schemas.microsoft.com/office/drawing/2010/main">
-        <mc:Choice Requires="a14">
+      <mc:AlternateContent xmlns:mc="http://schemas.openxmlformats.org/markup-compatibility/2006">
+        <mc:Choice xmlns:a14="http://schemas.microsoft.com/office/drawing/2010/main" Requires="a14">
           <p:sp>
             <p:nvSpPr>
               <p:cNvPr id="11" name="TextBox 10">
@@ -7431,7 +7431,7 @@
                     <a:ea typeface="Times New Roman" panose="02020603050405020304" pitchFamily="18" charset="0"/>
                     <a:cs typeface="Times New Roman" panose="02020603050405020304" pitchFamily="18" charset="0"/>
                   </a:rPr>
-                  <a:t> (</a:t>
+                  <a:t> (например </a:t>
                 </a:r>
                 <a:r>
                   <a:rPr lang="ru-RU" sz="1600" dirty="0" err="1">
@@ -7462,7 +7462,7 @@
             </p:txBody>
           </p:sp>
         </mc:Choice>
-        <mc:Fallback xmlns="">
+        <mc:Fallback>
           <p:sp>
             <p:nvSpPr>
               <p:cNvPr id="11" name="TextBox 10">
@@ -8517,7 +8517,7 @@
         </p:nvSpPr>
         <p:spPr>
           <a:xfrm>
-            <a:off x="10759108" y="3428999"/>
+            <a:off x="10718940" y="3408278"/>
             <a:ext cx="1132237" cy="770969"/>
           </a:xfrm>
           <a:prstGeom prst="rect">

</xml_diff>